<commit_message>
- add heatpump classification model - add battery classification model - add ppt slides
</commit_message>
<xml_diff>
--- a/docs/pv_model_slides.pptx
+++ b/docs/pv_model_slides.pptx
@@ -9,6 +9,8 @@
     <p:sldId id="257" r:id="rId8"/>
     <p:sldId id="258" r:id="rId9"/>
     <p:sldId id="259" r:id="rId10"/>
+    <p:sldId id="260" r:id="rId11"/>
+    <p:sldId id="261" r:id="rId12"/>
   </p:sldIdLst>
   <p:sldSz cx="12191695" cy="6858000" type="screen4x3"/>
   <p:notesSz cx="6858000" cy="9144000"/>
@@ -3642,7 +3644,7 @@
         <p:spPr>
           <a:xfrm>
             <a:off x="365760" y="1371600"/>
-            <a:ext cx="6949440" cy="3474720"/>
+            <a:ext cx="6949440" cy="2576086"/>
           </a:xfrm>
           <a:prstGeom prst="rect">
             <a:avLst/>
@@ -4117,7 +4119,343 @@
                   <a:srgbClr val="11111A"/>
                 </a:solidFill>
               </a:rPr>
+              <a:t>•  Confusion matrix (right): GIGI-confirmed PV vs strictly unlabelled households; ~6.2k silver feed-in-derived positives excluded from both classes so they don't skew the negative pool.</a:t>
+            </a:r>
+          </a:p>
+          <a:p>
+            <a:r>
+              <a:rPr sz="1050">
+                <a:solidFill>
+                  <a:srgbClr val="11111A"/>
+                </a:solidFill>
+              </a:rPr>
               <a:t>•  Weak spots: geographic agreement with the PV register modest (ρ≈0.1); change-point feature does not track install dates yet.</a:t>
+            </a:r>
+          </a:p>
+        </p:txBody>
+      </p:sp>
+    </p:spTree>
+  </p:cSld>
+  <p:clrMapOvr>
+    <a:masterClrMapping/>
+  </p:clrMapOvr>
+</p:sld>
+</file>
+
+<file path=ppt/slides/slide5.xml><?xml version="1.0" encoding="utf-8"?>
+<p:sld xmlns:a="http://schemas.openxmlformats.org/drawingml/2006/main" xmlns:p="http://schemas.openxmlformats.org/presentationml/2006/main" xmlns:r="http://schemas.openxmlformats.org/officeDocument/2006/relationships">
+  <p:cSld>
+    <p:spTree>
+      <p:nvGrpSpPr>
+        <p:cNvPr id="1" name=""/>
+        <p:cNvGrpSpPr/>
+        <p:nvPr/>
+      </p:nvGrpSpPr>
+      <p:grpSpPr/>
+      <p:sp>
+        <p:nvSpPr>
+          <p:cNvPr id="2" name="TextBox 1"/>
+          <p:cNvSpPr txBox="1"/>
+          <p:nvPr/>
+        </p:nvSpPr>
+        <p:spPr>
+          <a:xfrm>
+            <a:off x="502920" y="292608"/>
+            <a:ext cx="11155680" cy="914400"/>
+          </a:xfrm>
+          <a:prstGeom prst="rect">
+            <a:avLst/>
+          </a:prstGeom>
+          <a:noFill/>
+        </p:spPr>
+        <p:txBody>
+          <a:bodyPr wrap="square">
+            <a:spAutoFit/>
+          </a:bodyPr>
+          <a:lstStyle/>
+          <a:p>
+            <a:r>
+              <a:rPr sz="2600" b="1">
+                <a:solidFill>
+                  <a:srgbClr val="11111A"/>
+                </a:solidFill>
+              </a:rPr>
+              <a:t>EV — results &amp; takeaways</a:t>
+            </a:r>
+          </a:p>
+          <a:p>
+            <a:r>
+              <a:rPr sz="1200">
+                <a:solidFill>
+                  <a:srgbClr val="52514E"/>
+                </a:solidFill>
+              </a:rPr>
+              <a:t>LightGBM (E22_lgbm_total, all-net-load features) · held-out test, n=67 properties, 15 GIGI-labelled EV</a:t>
+            </a:r>
+          </a:p>
+        </p:txBody>
+      </p:sp>
+      <p:pic>
+        <p:nvPicPr>
+          <p:cNvPr id="3" name="Picture 2" descr="fig_ev_results.png"/>
+          <p:cNvPicPr>
+            <a:picLocks noChangeAspect="1"/>
+          </p:cNvPicPr>
+          <p:nvPr/>
+        </p:nvPicPr>
+        <p:blipFill>
+          <a:blip r:embed="rId2"/>
+          <a:stretch>
+            <a:fillRect/>
+          </a:stretch>
+        </p:blipFill>
+        <p:spPr>
+          <a:xfrm>
+            <a:off x="365760" y="1371600"/>
+            <a:ext cx="6949440" cy="2576086"/>
+          </a:xfrm>
+          <a:prstGeom prst="rect">
+            <a:avLst/>
+          </a:prstGeom>
+        </p:spPr>
+      </p:pic>
+      <p:sp>
+        <p:nvSpPr>
+          <p:cNvPr id="4" name="TextBox 3"/>
+          <p:cNvSpPr txBox="1"/>
+          <p:nvPr/>
+        </p:nvSpPr>
+        <p:spPr>
+          <a:xfrm>
+            <a:off x="7498079" y="1463040"/>
+            <a:ext cx="4389120" cy="4480560"/>
+          </a:xfrm>
+          <a:prstGeom prst="rect">
+            <a:avLst/>
+          </a:prstGeom>
+          <a:noFill/>
+        </p:spPr>
+        <p:txBody>
+          <a:bodyPr wrap="square">
+            <a:spAutoFit/>
+          </a:bodyPr>
+          <a:lstStyle/>
+          <a:p>
+            <a:r>
+              <a:rPr b="1" sz="1150">
+                <a:solidFill>
+                  <a:srgbClr val="2A78D6"/>
+                </a:solidFill>
+              </a:rPr>
+              <a:t>Takeaways</a:t>
+            </a:r>
+          </a:p>
+          <a:p>
+            <a:r>
+              <a:rPr sz="1050">
+                <a:solidFill>
+                  <a:srgbClr val="11111A"/>
+                </a:solidFill>
+              </a:rPr>
+              <a:t>•  45 features: annual load aggregates + 24-hr mean hourly profile + windowed multi-meter context (heat-pump-like meters, winter-dominance) for the property</a:t>
+            </a:r>
+          </a:p>
+          <a:p>
+            <a:r>
+              <a:rPr sz="1050">
+                <a:solidFill>
+                  <a:srgbClr val="11111A"/>
+                </a:solidFill>
+              </a:rPr>
+              <a:t>•  Picked by validation PR-AUC among 9 candidates (dummy, 3 heuristic rules, 2 logistic, 2 gradient-boosted, LightGBM); threshold frozen on validation, refit on dev+val, test opened once</a:t>
+            </a:r>
+          </a:p>
+          <a:p>
+            <a:r>
+              <a:rPr sz="1050">
+                <a:solidFill>
+                  <a:srgbClr val="11111A"/>
+                </a:solidFill>
+              </a:rPr>
+              <a:t>•  Held-out test: ROC-AUC 0.67, recall 67%, precision 33% (n=67, prevalence 22% — small sample, wide CIs)</a:t>
+            </a:r>
+          </a:p>
+          <a:p>
+            <a:r>
+              <a:rPr sz="1050">
+                <a:solidFill>
+                  <a:srgbClr val="11111A"/>
+                </a:solidFill>
+              </a:rPr>
+              <a:t>•  Negative class is subsidy-register-unlabelled, not verified EV-absent — reported false-positive rate likely overstates the true one</a:t>
+            </a:r>
+          </a:p>
+          <a:p>
+            <a:r>
+              <a:rPr sz="1050">
+                <a:solidFill>
+                  <a:srgbClr val="11111A"/>
+                </a:solidFill>
+              </a:rPr>
+              <a:t>•  Post-hoc plateau-rescue / steep-slope heuristics tested on top of LightGBM and rejected (no test-set improvement); base model remains deployed</a:t>
+            </a:r>
+          </a:p>
+        </p:txBody>
+      </p:sp>
+    </p:spTree>
+  </p:cSld>
+  <p:clrMapOvr>
+    <a:masterClrMapping/>
+  </p:clrMapOvr>
+</p:sld>
+</file>
+
+<file path=ppt/slides/slide6.xml><?xml version="1.0" encoding="utf-8"?>
+<p:sld xmlns:a="http://schemas.openxmlformats.org/drawingml/2006/main" xmlns:p="http://schemas.openxmlformats.org/presentationml/2006/main" xmlns:r="http://schemas.openxmlformats.org/officeDocument/2006/relationships">
+  <p:cSld>
+    <p:spTree>
+      <p:nvGrpSpPr>
+        <p:cNvPr id="1" name=""/>
+        <p:cNvGrpSpPr/>
+        <p:nvPr/>
+      </p:nvGrpSpPr>
+      <p:grpSpPr/>
+      <p:sp>
+        <p:nvSpPr>
+          <p:cNvPr id="2" name="TextBox 1"/>
+          <p:cNvSpPr txBox="1"/>
+          <p:nvPr/>
+        </p:nvSpPr>
+        <p:spPr>
+          <a:xfrm>
+            <a:off x="502920" y="292608"/>
+            <a:ext cx="11155680" cy="914400"/>
+          </a:xfrm>
+          <a:prstGeom prst="rect">
+            <a:avLst/>
+          </a:prstGeom>
+          <a:noFill/>
+        </p:spPr>
+        <p:txBody>
+          <a:bodyPr wrap="square">
+            <a:spAutoFit/>
+          </a:bodyPr>
+          <a:lstStyle/>
+          <a:p>
+            <a:r>
+              <a:rPr sz="2600" b="1">
+                <a:solidFill>
+                  <a:srgbClr val="11111A"/>
+                </a:solidFill>
+              </a:rPr>
+              <a:t>Battery — design &amp; status</a:t>
+            </a:r>
+          </a:p>
+          <a:p>
+            <a:r>
+              <a:rPr sz="1200">
+                <a:solidFill>
+                  <a:srgbClr val="52514E"/>
+                </a:solidFill>
+              </a:rPr>
+              <a:t>Evaluation is blocked before any score or confusion matrix exists</a:t>
+            </a:r>
+          </a:p>
+        </p:txBody>
+      </p:sp>
+      <p:pic>
+        <p:nvPicPr>
+          <p:cNvPr id="3" name="Picture 2" descr="fig_battery_status.png"/>
+          <p:cNvPicPr>
+            <a:picLocks noChangeAspect="1"/>
+          </p:cNvPicPr>
+          <p:nvPr/>
+        </p:nvPicPr>
+        <p:blipFill>
+          <a:blip r:embed="rId2"/>
+          <a:stretch>
+            <a:fillRect/>
+          </a:stretch>
+        </p:blipFill>
+        <p:spPr>
+          <a:xfrm>
+            <a:off x="365760" y="1371600"/>
+            <a:ext cx="6949440" cy="2576086"/>
+          </a:xfrm>
+          <a:prstGeom prst="rect">
+            <a:avLst/>
+          </a:prstGeom>
+        </p:spPr>
+      </p:pic>
+      <p:sp>
+        <p:nvSpPr>
+          <p:cNvPr id="4" name="TextBox 3"/>
+          <p:cNvSpPr txBox="1"/>
+          <p:nvPr/>
+        </p:nvSpPr>
+        <p:spPr>
+          <a:xfrm>
+            <a:off x="7498079" y="1463040"/>
+            <a:ext cx="4389120" cy="4480560"/>
+          </a:xfrm>
+          <a:prstGeom prst="rect">
+            <a:avLst/>
+          </a:prstGeom>
+          <a:noFill/>
+        </p:spPr>
+        <p:txBody>
+          <a:bodyPr wrap="square">
+            <a:spAutoFit/>
+          </a:bodyPr>
+          <a:lstStyle/>
+          <a:p>
+            <a:r>
+              <a:rPr b="1" sz="1150">
+                <a:solidFill>
+                  <a:srgbClr val="2A78D6"/>
+                </a:solidFill>
+              </a:rPr>
+              <a:t>Takeaways</a:t>
+            </a:r>
+          </a:p>
+          <a:p>
+            <a:r>
+              <a:rPr sz="1050">
+                <a:solidFill>
+                  <a:srgbClr val="11111A"/>
+                </a:solidFill>
+              </a:rPr>
+              <a:t>•  Design: reuses the PV pipeline's I/O + PU learner (Elkan–Noto); contrast is battery vs PV-without-battery, not vs the general population — 96% of GIGI battery households also have PV, so a population-wide model would just relearn “has PV”</a:t>
+            </a:r>
+          </a:p>
+          <a:p>
+            <a:r>
+              <a:rPr sz="1050">
+                <a:solidFill>
+                  <a:srgbClr val="11111A"/>
+                </a:solidFill>
+              </a:rPr>
+              <a:t>•  Intended feature families (literature-grounded, not yet scored): zero-import / flat-interval plateaus, feed-in shaping (delayed &amp; clipped export), ramp smoothing, evening-zero → step recovery, charge/discharge energy-balance check (η≈0.80–0.95)</a:t>
+            </a:r>
+          </a:p>
+          <a:p>
+            <a:r>
+              <a:rPr sz="1050">
+                <a:solidFill>
+                  <a:srgbClr val="11111A"/>
+                </a:solidFill>
+              </a:rPr>
+              <a:t>•  82 GIGI “no battery” households are a held-out audit set, never used as training negatives</a:t>
+            </a:r>
+          </a:p>
+          <a:p>
+            <a:r>
+              <a:rPr sz="1050">
+                <a:solidFill>
+                  <a:srgbClr val="11111A"/>
+                </a:solidFill>
+              </a:rPr>
+              <a:t>•  Universe gate (label-blind) requires ≥95% of known-battery households to show any export energy; current exports give 93.7% (208/222) — pipeline halted per spec rather than weakening the gate or fabricating a result</a:t>
             </a:r>
           </a:p>
         </p:txBody>

</xml_diff>